<commit_message>
fix: move body text placeholders up in T4 slides 3,5,6 (1cm/0.2in)
</commit_message>
<xml_diff>
--- a/templates/shablonlar/4.pptx
+++ b/templates/shablonlar/4.pptx
@@ -13559,7 +13559,7 @@
         </p:nvSpPr>
         <p:spPr>
           <a:xfrm>
-            <a:off x="720000" y="2000249"/>
+            <a:off x="720000" y="1640250"/>
             <a:ext cx="3588600" cy="2093119"/>
           </a:xfrm>
           <a:prstGeom prst="rect">
@@ -13937,7 +13937,7 @@
         </p:nvSpPr>
         <p:spPr>
           <a:xfrm>
-            <a:off x="5084378" y="1572587"/>
+            <a:off x="5084378" y="1389707"/>
             <a:ext cx="2947800" cy="2875200"/>
           </a:xfrm>
           <a:prstGeom prst="rect">
@@ -13975,7 +13975,7 @@
         </p:nvSpPr>
         <p:spPr>
           <a:xfrm>
-            <a:off x="1111822" y="1572587"/>
+            <a:off x="1111822" y="1389707"/>
             <a:ext cx="2947800" cy="2875200"/>
           </a:xfrm>
           <a:prstGeom prst="rect">
@@ -14183,7 +14183,7 @@
         </p:nvSpPr>
         <p:spPr>
           <a:xfrm>
-            <a:off x="549511" y="1794423"/>
+            <a:off x="549511" y="1434424"/>
             <a:ext cx="3759089" cy="2564445"/>
           </a:xfrm>
           <a:prstGeom prst="rect">

</xml_diff>